<commit_message>
koreatech-db: 주차·이론 슬라이드 재생성 — 코드 글꼴 D2Coding(deckgen v2.5.0, <> 구분)
Co-Authored-By: Claude Opus 5.5 <noreply@anthropic.com>
</commit_message>
<xml_diff>
--- a/koreatech-db/theory/이론1장_경영과_데이터.pptx
+++ b/koreatech-db/theory/이론1장_경영과_데이터.pptx
@@ -27426,9 +27426,9 @@
                 <a:solidFill>
                   <a:srgbClr val="7A869C"/>
                 </a:solidFill>
-                <a:latin typeface="나눔고딕코딩"/>
-                <a:ea typeface="나눔고딕코딩"/>
-                <a:cs typeface="나눔고딕코딩"/>
+                <a:latin typeface="D2Coding"/>
+                <a:ea typeface="D2Coding"/>
+                <a:cs typeface="D2Coding"/>
               </a:rPr>
               <a:t>1</a:t>
             </a:r>
@@ -27444,9 +27444,9 @@
                 <a:solidFill>
                   <a:srgbClr val="7A869C"/>
                 </a:solidFill>
-                <a:latin typeface="나눔고딕코딩"/>
-                <a:ea typeface="나눔고딕코딩"/>
-                <a:cs typeface="나눔고딕코딩"/>
+                <a:latin typeface="D2Coding"/>
+                <a:ea typeface="D2Coding"/>
+                <a:cs typeface="D2Coding"/>
               </a:rPr>
               <a:t>2</a:t>
             </a:r>
@@ -27462,9 +27462,9 @@
                 <a:solidFill>
                   <a:srgbClr val="7A869C"/>
                 </a:solidFill>
-                <a:latin typeface="나눔고딕코딩"/>
-                <a:ea typeface="나눔고딕코딩"/>
-                <a:cs typeface="나눔고딕코딩"/>
+                <a:latin typeface="D2Coding"/>
+                <a:ea typeface="D2Coding"/>
+                <a:cs typeface="D2Coding"/>
               </a:rPr>
               <a:t>3</a:t>
             </a:r>
@@ -27480,9 +27480,9 @@
                 <a:solidFill>
                   <a:srgbClr val="7A869C"/>
                 </a:solidFill>
-                <a:latin typeface="나눔고딕코딩"/>
-                <a:ea typeface="나눔고딕코딩"/>
-                <a:cs typeface="나눔고딕코딩"/>
+                <a:latin typeface="D2Coding"/>
+                <a:ea typeface="D2Coding"/>
+                <a:cs typeface="D2Coding"/>
               </a:rPr>
               <a:t>4</a:t>
             </a:r>
@@ -27498,9 +27498,9 @@
                 <a:solidFill>
                   <a:srgbClr val="7A869C"/>
                 </a:solidFill>
-                <a:latin typeface="나눔고딕코딩"/>
-                <a:ea typeface="나눔고딕코딩"/>
-                <a:cs typeface="나눔고딕코딩"/>
+                <a:latin typeface="D2Coding"/>
+                <a:ea typeface="D2Coding"/>
+                <a:cs typeface="D2Coding"/>
               </a:rPr>
               <a:t>5</a:t>
             </a:r>
@@ -27516,9 +27516,9 @@
                 <a:solidFill>
                   <a:srgbClr val="7A869C"/>
                 </a:solidFill>
-                <a:latin typeface="나눔고딕코딩"/>
-                <a:ea typeface="나눔고딕코딩"/>
-                <a:cs typeface="나눔고딕코딩"/>
+                <a:latin typeface="D2Coding"/>
+                <a:ea typeface="D2Coding"/>
+                <a:cs typeface="D2Coding"/>
               </a:rPr>
               <a:t>6</a:t>
             </a:r>
@@ -27534,9 +27534,9 @@
                 <a:solidFill>
                   <a:srgbClr val="7A869C"/>
                 </a:solidFill>
-                <a:latin typeface="나눔고딕코딩"/>
-                <a:ea typeface="나눔고딕코딩"/>
-                <a:cs typeface="나눔고딕코딩"/>
+                <a:latin typeface="D2Coding"/>
+                <a:ea typeface="D2Coding"/>
+                <a:cs typeface="D2Coding"/>
               </a:rPr>
               <a:t>7</a:t>
             </a:r>
@@ -27552,9 +27552,9 @@
                 <a:solidFill>
                   <a:srgbClr val="7A869C"/>
                 </a:solidFill>
-                <a:latin typeface="나눔고딕코딩"/>
-                <a:ea typeface="나눔고딕코딩"/>
-                <a:cs typeface="나눔고딕코딩"/>
+                <a:latin typeface="D2Coding"/>
+                <a:ea typeface="D2Coding"/>
+                <a:cs typeface="D2Coding"/>
               </a:rPr>
               <a:t>8</a:t>
             </a:r>
@@ -27570,9 +27570,9 @@
                 <a:solidFill>
                   <a:srgbClr val="7A869C"/>
                 </a:solidFill>
-                <a:latin typeface="나눔고딕코딩"/>
-                <a:ea typeface="나눔고딕코딩"/>
-                <a:cs typeface="나눔고딕코딩"/>
+                <a:latin typeface="D2Coding"/>
+                <a:ea typeface="D2Coding"/>
+                <a:cs typeface="D2Coding"/>
               </a:rPr>
               <a:t>9</a:t>
             </a:r>
@@ -27588,9 +27588,9 @@
                 <a:solidFill>
                   <a:srgbClr val="7A869C"/>
                 </a:solidFill>
-                <a:latin typeface="나눔고딕코딩"/>
-                <a:ea typeface="나눔고딕코딩"/>
-                <a:cs typeface="나눔고딕코딩"/>
+                <a:latin typeface="D2Coding"/>
+                <a:ea typeface="D2Coding"/>
+                <a:cs typeface="D2Coding"/>
               </a:rPr>
               <a:t>10</a:t>
             </a:r>
@@ -27606,9 +27606,9 @@
                 <a:solidFill>
                   <a:srgbClr val="7A869C"/>
                 </a:solidFill>
-                <a:latin typeface="나눔고딕코딩"/>
-                <a:ea typeface="나눔고딕코딩"/>
-                <a:cs typeface="나눔고딕코딩"/>
+                <a:latin typeface="D2Coding"/>
+                <a:ea typeface="D2Coding"/>
+                <a:cs typeface="D2Coding"/>
               </a:rPr>
               <a:t>11</a:t>
             </a:r>
@@ -27624,9 +27624,9 @@
                 <a:solidFill>
                   <a:srgbClr val="7A869C"/>
                 </a:solidFill>
-                <a:latin typeface="나눔고딕코딩"/>
-                <a:ea typeface="나눔고딕코딩"/>
-                <a:cs typeface="나눔고딕코딩"/>
+                <a:latin typeface="D2Coding"/>
+                <a:ea typeface="D2Coding"/>
+                <a:cs typeface="D2Coding"/>
               </a:rPr>
               <a:t>12</a:t>
             </a:r>
@@ -27665,9 +27665,9 @@
                 <a:solidFill>
                   <a:srgbClr val="E6EAF2"/>
                 </a:solidFill>
-                <a:latin typeface="나눔고딕코딩"/>
-                <a:ea typeface="나눔고딕코딩"/>
-                <a:cs typeface="나눔고딕코딩"/>
+                <a:latin typeface="D2Coding"/>
+                <a:ea typeface="D2Coding"/>
+                <a:cs typeface="D2Coding"/>
               </a:rPr>
               <a:t>-- 데이터: order_items에 흩어진 25건의 주문 상세</a:t>
             </a:r>
@@ -27683,9 +27683,9 @@
                 <a:solidFill>
                   <a:srgbClr val="E6EAF2"/>
                 </a:solidFill>
-                <a:latin typeface="나눔고딕코딩"/>
-                <a:ea typeface="나눔고딕코딩"/>
-                <a:cs typeface="나눔고딕코딩"/>
+                <a:latin typeface="D2Coding"/>
+                <a:ea typeface="D2Coding"/>
+                <a:cs typeface="D2Coding"/>
               </a:rPr>
               <a:t>-- 정보: 고객 등급별 매출액 (취소 주문 제외)</a:t>
             </a:r>
@@ -27701,9 +27701,9 @@
                 <a:solidFill>
                   <a:srgbClr val="E6EAF2"/>
                 </a:solidFill>
-                <a:latin typeface="나눔고딕코딩"/>
-                <a:ea typeface="나눔고딕코딩"/>
-                <a:cs typeface="나눔고딕코딩"/>
+                <a:latin typeface="D2Coding"/>
+                <a:ea typeface="D2Coding"/>
+                <a:cs typeface="D2Coding"/>
               </a:rPr>
               <a:t>SELECT c.grade,</a:t>
             </a:r>
@@ -27719,9 +27719,9 @@
                 <a:solidFill>
                   <a:srgbClr val="E6EAF2"/>
                 </a:solidFill>
-                <a:latin typeface="나눔고딕코딩"/>
-                <a:ea typeface="나눔고딕코딩"/>
-                <a:cs typeface="나눔고딕코딩"/>
+                <a:latin typeface="D2Coding"/>
+                <a:ea typeface="D2Coding"/>
+                <a:cs typeface="D2Coding"/>
               </a:rPr>
               <a:t>       SUM(i.qty * i.unit_price) AS 매출액</a:t>
             </a:r>
@@ -27737,9 +27737,9 @@
                 <a:solidFill>
                   <a:srgbClr val="E6EAF2"/>
                 </a:solidFill>
-                <a:latin typeface="나눔고딕코딩"/>
-                <a:ea typeface="나눔고딕코딩"/>
-                <a:cs typeface="나눔고딕코딩"/>
+                <a:latin typeface="D2Coding"/>
+                <a:ea typeface="D2Coding"/>
+                <a:cs typeface="D2Coding"/>
               </a:rPr>
               <a:t>FROM   customers c</a:t>
             </a:r>
@@ -27755,9 +27755,9 @@
                 <a:solidFill>
                   <a:srgbClr val="E6EAF2"/>
                 </a:solidFill>
-                <a:latin typeface="나눔고딕코딩"/>
-                <a:ea typeface="나눔고딕코딩"/>
-                <a:cs typeface="나눔고딕코딩"/>
+                <a:latin typeface="D2Coding"/>
+                <a:ea typeface="D2Coding"/>
+                <a:cs typeface="D2Coding"/>
               </a:rPr>
               <a:t>JOIN   orders      o ON c.cust_id  = o.cust_id</a:t>
             </a:r>
@@ -27773,9 +27773,9 @@
                 <a:solidFill>
                   <a:srgbClr val="E6EAF2"/>
                 </a:solidFill>
-                <a:latin typeface="나눔고딕코딩"/>
-                <a:ea typeface="나눔고딕코딩"/>
-                <a:cs typeface="나눔고딕코딩"/>
+                <a:latin typeface="D2Coding"/>
+                <a:ea typeface="D2Coding"/>
+                <a:cs typeface="D2Coding"/>
               </a:rPr>
               <a:t>JOIN   order_items i ON o.order_id = i.order_id</a:t>
             </a:r>
@@ -27791,9 +27791,9 @@
                 <a:solidFill>
                   <a:srgbClr val="E6EAF2"/>
                 </a:solidFill>
-                <a:latin typeface="나눔고딕코딩"/>
-                <a:ea typeface="나눔고딕코딩"/>
-                <a:cs typeface="나눔고딕코딩"/>
+                <a:latin typeface="D2Coding"/>
+                <a:ea typeface="D2Coding"/>
+                <a:cs typeface="D2Coding"/>
               </a:rPr>
               <a:t>WHERE  o.status &lt;&gt; '취소'</a:t>
             </a:r>
@@ -27809,9 +27809,9 @@
                 <a:solidFill>
                   <a:srgbClr val="E6EAF2"/>
                 </a:solidFill>
-                <a:latin typeface="나눔고딕코딩"/>
-                <a:ea typeface="나눔고딕코딩"/>
-                <a:cs typeface="나눔고딕코딩"/>
+                <a:latin typeface="D2Coding"/>
+                <a:ea typeface="D2Coding"/>
+                <a:cs typeface="D2Coding"/>
               </a:rPr>
               <a:t>GROUP  BY c.grade</a:t>
             </a:r>
@@ -27827,9 +27827,9 @@
                 <a:solidFill>
                   <a:srgbClr val="E6EAF2"/>
                 </a:solidFill>
-                <a:latin typeface="나눔고딕코딩"/>
-                <a:ea typeface="나눔고딕코딩"/>
-                <a:cs typeface="나눔고딕코딩"/>
+                <a:latin typeface="D2Coding"/>
+                <a:ea typeface="D2Coding"/>
+                <a:cs typeface="D2Coding"/>
               </a:rPr>
               <a:t>ORDER  BY 매출액 DESC;</a:t>
             </a:r>
@@ -27845,9 +27845,9 @@
                 <a:solidFill>
                   <a:srgbClr val="E6EAF2"/>
                 </a:solidFill>
-                <a:latin typeface="나눔고딕코딩"/>
-                <a:ea typeface="나눔고딕코딩"/>
-                <a:cs typeface="나눔고딕코딩"/>
+                <a:latin typeface="D2Coding"/>
+                <a:ea typeface="D2Coding"/>
+                <a:cs typeface="D2Coding"/>
               </a:rPr>
               <a:t>-- "어느 등급 고객이 매출을 이끄는가"라는</a:t>
             </a:r>
@@ -27863,9 +27863,9 @@
                 <a:solidFill>
                   <a:srgbClr val="E6EAF2"/>
                 </a:solidFill>
-                <a:latin typeface="나눔고딕코딩"/>
-                <a:ea typeface="나눔고딕코딩"/>
-                <a:cs typeface="나눔고딕코딩"/>
+                <a:latin typeface="D2Coding"/>
+                <a:ea typeface="D2Coding"/>
+                <a:cs typeface="D2Coding"/>
               </a:rPr>
               <a:t>-- 경영 질문에 대한 답이 곧 정보다.</a:t>
             </a:r>

</xml_diff>